<commit_message>
Regenerate midterm.pptx with N=15 results and updated method slides.
</commit_message>
<xml_diff>
--- a/midterm.pptx
+++ b/midterm.pptx
@@ -510,7 +510,8 @@
           <a:p>
             <a:r>
               <a:rPr lang="en-US" dirty="0"/>
-              <a:t/>
+              <a:t>Good morning. I am Hu Yunhan.
+Today I present Mayor Climate Game—a browser prototype studied with 15 completed session records in July 2026.</a:t>
             </a:r>
             <a:endParaRPr lang="en-US" dirty="0"/>
           </a:p>
@@ -598,7 +599,8 @@
           <a:p>
             <a:r>
               <a:rPr lang="en-US" dirty="0"/>
-              <a:t/>
+              <a:t>State the research question clearly.
+Hypothesis focuses on both declarative knowledge and safer siting behavior.</a:t>
             </a:r>
             <a:endParaRPr lang="en-US" dirty="0"/>
           </a:p>
@@ -686,7 +688,7 @@
           <a:p>
             <a:r>
               <a:rPr lang="en-US" dirty="0"/>
-              <a:t/>
+              <a:t>Keep background short; link to IEA cooling demand context if asked.</a:t>
             </a:r>
             <a:endParaRPr lang="en-US" dirty="0"/>
           </a:p>
@@ -774,7 +776,7 @@
           <a:p>
             <a:r>
               <a:rPr lang="en-US" dirty="0"/>
-              <a:t/>
+              <a:t>Cite Zheng et al. 2022, Guan et al. 2015, IEA 2023, neighbourhood game 2019.</a:t>
             </a:r>
             <a:endParaRPr lang="en-US" dirty="0"/>
           </a:p>
@@ -862,7 +864,8 @@
           <a:p>
             <a:r>
               <a:rPr lang="en-US" dirty="0"/>
-              <a:t/>
+              <a:t>Emphasize material boundaries: heuristic model, not professional simulation.
+Five pre/post exports share one sessionId (one tester, multiple playthroughs)—state honestly if asked.</a:t>
             </a:r>
             <a:endParaRPr lang="en-US" dirty="0"/>
           </a:p>
@@ -950,7 +953,9 @@
           <a:p>
             <a:r>
               <a:rPr lang="en-US" dirty="0"/>
-              <a:t/>
+              <a:t>15/15 ventilation correct.
+11/15 budget motivation yes.
+Point to spread between 0 t and 1440 t carbon outcomes.</a:t>
             </a:r>
             <a:endParaRPr lang="en-US" dirty="0"/>
           </a:p>
@@ -1038,7 +1043,8 @@
           <a:p>
             <a:r>
               <a:rPr lang="en-US" dirty="0"/>
-              <a:t/>
+              <a:t>Offer to open live demo if time allows.
+Acknowledge limitations openly—it strengthens credibility.</a:t>
             </a:r>
             <a:endParaRPr lang="en-US" dirty="0"/>
           </a:p>
@@ -1126,7 +1132,7 @@
           <a:p>
             <a:r>
               <a:rPr lang="en-US" dirty="0"/>
-              <a:t/>
+              <a:t>Full bibliography in paper.md and references.bib.</a:t>
             </a:r>
             <a:endParaRPr lang="en-US" dirty="0"/>
           </a:p>
@@ -1214,7 +1220,7 @@
           <a:p>
             <a:r>
               <a:rPr lang="en-US" dirty="0"/>
-              <a:t/>
+              <a:t>Pause for questions.</a:t>
             </a:r>
             <a:endParaRPr lang="en-US" dirty="0"/>
           </a:p>
@@ -1713,7 +1719,73 @@
       </p:sp>
       <p:sp>
         <p:nvSpPr>
-          <p:cNvPr id="5" name="Text 3"/>
+          <p:cNvPr id="5" name="Shape 3"/>
+          <p:cNvSpPr/>
+          <p:nvPr/>
+        </p:nvSpPr>
+        <p:spPr>
+          <a:xfrm>
+            <a:off x="502920" y="6144768"/>
+            <a:ext cx="11155680" cy="384048"/>
+          </a:xfrm>
+          <a:prstGeom prst="rect">
+            <a:avLst/>
+          </a:prstGeom>
+          <a:solidFill>
+            <a:srgbClr val="EEF4FA"/>
+          </a:solidFill>
+          <a:ln w="7620">
+            <a:solidFill>
+              <a:srgbClr val="2D6A9F"/>
+            </a:solidFill>
+            <a:prstDash val="solid"/>
+          </a:ln>
+        </p:spPr>
+      </p:sp>
+      <p:sp>
+        <p:nvSpPr>
+          <p:cNvPr id="6" name="Text 4"/>
+          <p:cNvSpPr/>
+          <p:nvPr/>
+        </p:nvSpPr>
+        <p:spPr>
+          <a:xfrm>
+            <a:off x="640080" y="6199632"/>
+            <a:ext cx="10881360" cy="292608"/>
+          </a:xfrm>
+          <a:prstGeom prst="rect">
+            <a:avLst/>
+          </a:prstGeom>
+          <a:noFill/>
+          <a:ln/>
+        </p:spPr>
+        <p:txBody>
+          <a:bodyPr wrap="square" lIns="0" tIns="0" rIns="0" bIns="0" rtlCol="0" anchor="ctr">
+            <a:normAutofit/>
+          </a:bodyPr>
+          <a:lstStyle/>
+          <a:p>
+            <a:pPr indent="0" marL="0">
+              <a:buNone/>
+            </a:pPr>
+            <a:r>
+              <a:rPr lang="en-US" sz="1000" dirty="0">
+                <a:solidFill>
+                  <a:srgbClr val="6B7280"/>
+                </a:solidFill>
+                <a:latin typeface="Times New Roman" pitchFamily="34" charset="0"/>
+                <a:ea typeface="Times New Roman" pitchFamily="34" charset="-122"/>
+                <a:cs typeface="Times New Roman" pitchFamily="34" charset="-120"/>
+              </a:rPr>
+              <a:t>Takeaway: A browser serious game for teaching urban energy, carbon, and ventilation tradeoffs (N=15 pilot sessions, July 2026).</a:t>
+            </a:r>
+            <a:endParaRPr lang="en-US" sz="1000" dirty="0"/>
+          </a:p>
+        </p:txBody>
+      </p:sp>
+      <p:sp>
+        <p:nvSpPr>
+          <p:cNvPr id="7" name="Text 5"/>
           <p:cNvSpPr/>
           <p:nvPr/>
         </p:nvSpPr>
@@ -1853,7 +1925,7 @@
         <p:spPr>
           <a:xfrm>
             <a:off x="731520" y="1417320"/>
-            <a:ext cx="10698480" cy="4206240"/>
+            <a:ext cx="10698480" cy="4023360"/>
           </a:xfrm>
           <a:prstGeom prst="rect">
             <a:avLst/>
@@ -1882,7 +1954,7 @@
                 <a:ea typeface="Times New Roman" pitchFamily="34" charset="-122"/>
                 <a:cs typeface="Times New Roman" pitchFamily="34" charset="-120"/>
               </a:rPr>
-              <a:t>Research Question: How does Mayor Climate Game affect energy layout choices for undergraduate students in a social science or urban climate class?</a:t>
+              <a:t>Research Question: How does Mayor Climate Game affect energy layout choices and post-play understanding of budget–carbon–ventilation tradeoffs?</a:t>
             </a:r>
             <a:endParaRPr lang="en-US" sz="1600" dirty="0"/>
           </a:p>
@@ -1911,7 +1983,7 @@
                 <a:ea typeface="Times New Roman" pitchFamily="34" charset="-122"/>
                 <a:cs typeface="Times New Roman" pitchFamily="34" charset="-120"/>
               </a:rPr>
-              <a:t>Hypothesis: I hypothesize that after using Mayor Climate Game, undergraduate students will choose fewer high-carbon coal plants and show better understanding of the tradeoff between cost, carbon emissions, and urban ventilation.</a:t>
+              <a:t>Hypothesis: After one round with live metrics, participants will avoid coal on ventilation-sensitive cells and show accurate understanding of the tradeoff on post-play measures.</a:t>
             </a:r>
             <a:endParaRPr lang="en-US" sz="1600" dirty="0"/>
           </a:p>
@@ -1919,7 +1991,73 @@
       </p:sp>
       <p:sp>
         <p:nvSpPr>
-          <p:cNvPr id="5" name="Text 3"/>
+          <p:cNvPr id="5" name="Shape 3"/>
+          <p:cNvSpPr/>
+          <p:nvPr/>
+        </p:nvSpPr>
+        <p:spPr>
+          <a:xfrm>
+            <a:off x="502920" y="6144768"/>
+            <a:ext cx="11155680" cy="384048"/>
+          </a:xfrm>
+          <a:prstGeom prst="rect">
+            <a:avLst/>
+          </a:prstGeom>
+          <a:solidFill>
+            <a:srgbClr val="EEF4FA"/>
+          </a:solidFill>
+          <a:ln w="7620">
+            <a:solidFill>
+              <a:srgbClr val="2D6A9F"/>
+            </a:solidFill>
+            <a:prstDash val="solid"/>
+          </a:ln>
+        </p:spPr>
+      </p:sp>
+      <p:sp>
+        <p:nvSpPr>
+          <p:cNvPr id="6" name="Text 4"/>
+          <p:cNvSpPr/>
+          <p:nvPr/>
+        </p:nvSpPr>
+        <p:spPr>
+          <a:xfrm>
+            <a:off x="640080" y="6199632"/>
+            <a:ext cx="10881360" cy="292608"/>
+          </a:xfrm>
+          <a:prstGeom prst="rect">
+            <a:avLst/>
+          </a:prstGeom>
+          <a:noFill/>
+          <a:ln/>
+        </p:spPr>
+        <p:txBody>
+          <a:bodyPr wrap="square" lIns="0" tIns="0" rIns="0" bIns="0" rtlCol="0" anchor="ctr">
+            <a:normAutofit/>
+          </a:bodyPr>
+          <a:lstStyle/>
+          <a:p>
+            <a:pPr indent="0" marL="0">
+              <a:buNone/>
+            </a:pPr>
+            <a:r>
+              <a:rPr lang="en-US" sz="1000" dirty="0">
+                <a:solidFill>
+                  <a:srgbClr val="6B7280"/>
+                </a:solidFill>
+                <a:latin typeface="Times New Roman" pitchFamily="34" charset="0"/>
+                <a:ea typeface="Times New Roman" pitchFamily="34" charset="-122"/>
+                <a:cs typeface="Times New Roman" pitchFamily="34" charset="-120"/>
+              </a:rPr>
+              <a:t>Takeaway: We ask whether one play session helps learners understand cost, carbon, and ventilation—and whether they avoid blocking airflow with coal.</a:t>
+            </a:r>
+            <a:endParaRPr lang="en-US" sz="1000" dirty="0"/>
+          </a:p>
+        </p:txBody>
+      </p:sp>
+      <p:sp>
+        <p:nvSpPr>
+          <p:cNvPr id="7" name="Text 5"/>
           <p:cNvSpPr/>
           <p:nvPr/>
         </p:nvSpPr>
@@ -2059,7 +2197,7 @@
         <p:spPr>
           <a:xfrm>
             <a:off x="685800" y="1143000"/>
-            <a:ext cx="10835640" cy="5166360"/>
+            <a:ext cx="10835640" cy="4754880"/>
           </a:xfrm>
           <a:prstGeom prst="rect">
             <a:avLst/>
@@ -2089,7 +2227,7 @@
                 <a:ea typeface="Times New Roman" pitchFamily="34" charset="-122"/>
                 <a:cs typeface="Times New Roman" pitchFamily="34" charset="-120"/>
               </a:rPr>
-              <a:t>Cities are facing hotter summers, higher cooling demand, and pressure to reduce carbon emissions.</a:t>
+              <a:t>Cities face hotter summers, higher cooling demand, and pressure to reduce carbon emissions.</a:t>
             </a:r>
             <a:endParaRPr lang="en-US" sz="1400" dirty="0"/>
           </a:p>
@@ -2110,7 +2248,7 @@
                 <a:ea typeface="Times New Roman" pitchFamily="34" charset="-122"/>
                 <a:cs typeface="Times New Roman" pitchFamily="34" charset="-120"/>
               </a:rPr>
-              <a:t>Urban heat is not only a weather problem. It is also connected to energy use, public health, and city planning.</a:t>
+              <a:t>Urban heat connects to energy use, public health, and planning—not weather alone.</a:t>
             </a:r>
             <a:endParaRPr lang="en-US" sz="1400" dirty="0"/>
           </a:p>
@@ -2131,7 +2269,7 @@
                 <a:ea typeface="Times New Roman" pitchFamily="34" charset="-122"/>
                 <a:cs typeface="Times New Roman" pitchFamily="34" charset="-120"/>
               </a:rPr>
-              <a:t>When a city depends only on air conditioning, electricity demand and emissions can rise. The International Energy Agency notes that cooling demand is growing fast, and that city design also matters.</a:t>
+              <a:t>When cities rely only on air conditioning, electricity demand and emissions can rise.</a:t>
             </a:r>
             <a:endParaRPr lang="en-US" sz="1400" dirty="0"/>
           </a:p>
@@ -2152,7 +2290,7 @@
                 <a:ea typeface="Times New Roman" pitchFamily="34" charset="-122"/>
                 <a:cs typeface="Times New Roman" pitchFamily="34" charset="-120"/>
               </a:rPr>
-              <a:t>My project asks a small version of this problem: if a player has limited money, will they still choose cleaner energy when the page shows the climate cost of each choice?</a:t>
+              <a:t>My project asks: with limited money, will players still choose cleaner energy when the page shows the climate cost of each choice?</a:t>
             </a:r>
             <a:endParaRPr lang="en-US" sz="1400" dirty="0"/>
           </a:p>
@@ -2160,7 +2298,73 @@
       </p:sp>
       <p:sp>
         <p:nvSpPr>
-          <p:cNvPr id="5" name="Text 3"/>
+          <p:cNvPr id="5" name="Shape 3"/>
+          <p:cNvSpPr/>
+          <p:nvPr/>
+        </p:nvSpPr>
+        <p:spPr>
+          <a:xfrm>
+            <a:off x="502920" y="6144768"/>
+            <a:ext cx="11155680" cy="384048"/>
+          </a:xfrm>
+          <a:prstGeom prst="rect">
+            <a:avLst/>
+          </a:prstGeom>
+          <a:solidFill>
+            <a:srgbClr val="EEF4FA"/>
+          </a:solidFill>
+          <a:ln w="7620">
+            <a:solidFill>
+              <a:srgbClr val="2D6A9F"/>
+            </a:solidFill>
+            <a:prstDash val="solid"/>
+          </a:ln>
+        </p:spPr>
+      </p:sp>
+      <p:sp>
+        <p:nvSpPr>
+          <p:cNvPr id="6" name="Text 4"/>
+          <p:cNvSpPr/>
+          <p:nvPr/>
+        </p:nvSpPr>
+        <p:spPr>
+          <a:xfrm>
+            <a:off x="640080" y="6199632"/>
+            <a:ext cx="10881360" cy="292608"/>
+          </a:xfrm>
+          <a:prstGeom prst="rect">
+            <a:avLst/>
+          </a:prstGeom>
+          <a:noFill/>
+          <a:ln/>
+        </p:spPr>
+        <p:txBody>
+          <a:bodyPr wrap="square" lIns="0" tIns="0" rIns="0" bIns="0" rtlCol="0" anchor="ctr">
+            <a:normAutofit/>
+          </a:bodyPr>
+          <a:lstStyle/>
+          <a:p>
+            <a:pPr indent="0" marL="0">
+              <a:buNone/>
+            </a:pPr>
+            <a:r>
+              <a:rPr lang="en-US" sz="1000" dirty="0">
+                <a:solidFill>
+                  <a:srgbClr val="6B7280"/>
+                </a:solidFill>
+                <a:latin typeface="Times New Roman" pitchFamily="34" charset="0"/>
+                <a:ea typeface="Times New Roman" pitchFamily="34" charset="-122"/>
+                <a:cs typeface="Times New Roman" pitchFamily="34" charset="-120"/>
+              </a:rPr>
+              <a:t>Takeaway: Cities must balance cheap energy, low carbon, and good airflow—this game makes those tradeoffs visible without expert simulation tools.</a:t>
+            </a:r>
+            <a:endParaRPr lang="en-US" sz="1000" dirty="0"/>
+          </a:p>
+        </p:txBody>
+      </p:sp>
+      <p:sp>
+        <p:nvSpPr>
+          <p:cNvPr id="7" name="Text 5"/>
           <p:cNvSpPr/>
           <p:nvPr/>
         </p:nvSpPr>
@@ -2300,7 +2504,7 @@
         <p:spPr>
           <a:xfrm>
             <a:off x="685800" y="1143000"/>
-            <a:ext cx="10835640" cy="5166360"/>
+            <a:ext cx="10835640" cy="4754880"/>
           </a:xfrm>
           <a:prstGeom prst="rect">
             <a:avLst/>
@@ -2330,7 +2534,7 @@
                 <a:ea typeface="Times New Roman" pitchFamily="34" charset="-122"/>
                 <a:cs typeface="Times New Roman" pitchFamily="34" charset="-120"/>
               </a:rPr>
-              <a:t>Research on urban ventilation corridors shows that wind paths can help cities move heat and pollution out of dense areas. The Beijing and Guiyang cases show that parks, green space, water systems, roads, and prevailing wind direction can all be part of ventilation planning.</a:t>
+              <a:t>Urban ventilation corridors help move heat and pollution when siting respects airflow (Beijing, Guiyang cases).</a:t>
             </a:r>
             <a:endParaRPr lang="en-US" sz="1300" dirty="0"/>
           </a:p>
@@ -2351,7 +2555,7 @@
                 <a:ea typeface="Times New Roman" pitchFamily="34" charset="-122"/>
                 <a:cs typeface="Times New Roman" pitchFamily="34" charset="-120"/>
               </a:rPr>
-              <a:t>Other studies use GIS, remote sensing, WRF, and CFD to find heat islands and ventilation barriers. These tools are powerful, but they are hard for non-experts to use.</a:t>
+              <a:t>GIS, WRF, and CFD tools are powerful but hard for non-experts to use in a short class session.</a:t>
             </a:r>
             <a:endParaRPr lang="en-US" sz="1300" dirty="0"/>
           </a:p>
@@ -2372,7 +2576,7 @@
                 <a:ea typeface="Times New Roman" pitchFamily="34" charset="-122"/>
                 <a:cs typeface="Times New Roman" pitchFamily="34" charset="-120"/>
               </a:rPr>
-              <a:t>The International Energy Agency argues that cooling is not only about air conditioners. Building design, natural ventilation, and urban green space can reduce cooling pressure.</a:t>
+              <a:t>IEA: cooling is not only about air conditioners—design and ventilation matter.</a:t>
             </a:r>
             <a:endParaRPr lang="en-US" sz="1300" dirty="0"/>
           </a:p>
@@ -2393,36 +2597,81 @@
                 <a:ea typeface="Times New Roman" pitchFamily="34" charset="-122"/>
                 <a:cs typeface="Times New Roman" pitchFamily="34" charset="-120"/>
               </a:rPr>
-              <a:t>Serious games offer another path. Energy and heat-planning games can help non-expert users learn tradeoffs by making choices. This supports my project: a small browser game can make an abstract planning problem easier to understand.</a:t>
+              <a:t>Serious games let learners explore tradeoffs through choices; my gap is a lightweight browser tool that also logs research data.</a:t>
             </a:r>
             <a:endParaRPr lang="en-US" sz="1300" dirty="0"/>
           </a:p>
-          <a:p>
-            <a:pPr marL="177800" indent="-177800">
-              <a:lnSpc>
-                <a:spcPct val="115000"/>
-              </a:lnSpc>
-              <a:buSzPct val="100000"/>
-              <a:buChar char="•"/>
-            </a:pPr>
-            <a:r>
-              <a:rPr lang="en-US" sz="1300" dirty="0">
-                <a:solidFill>
-                  <a:srgbClr val="111827"/>
-                </a:solidFill>
-                <a:latin typeface="Times New Roman" pitchFamily="34" charset="0"/>
-                <a:ea typeface="Times New Roman" pitchFamily="34" charset="-122"/>
-                <a:cs typeface="Times New Roman" pitchFamily="34" charset="-120"/>
-              </a:rPr>
-              <a:t>The gap is that many tools are either professional simulation tools or public education games. My project is a small research prototype that both teaches a concept and records player choices.</a:t>
-            </a:r>
-            <a:endParaRPr lang="en-US" sz="1300" dirty="0"/>
-          </a:p>
-        </p:txBody>
-      </p:sp>
-      <p:sp>
-        <p:nvSpPr>
-          <p:cNvPr id="5" name="Text 3"/>
+        </p:txBody>
+      </p:sp>
+      <p:sp>
+        <p:nvSpPr>
+          <p:cNvPr id="5" name="Shape 3"/>
+          <p:cNvSpPr/>
+          <p:nvPr/>
+        </p:nvSpPr>
+        <p:spPr>
+          <a:xfrm>
+            <a:off x="502920" y="6144768"/>
+            <a:ext cx="11155680" cy="384048"/>
+          </a:xfrm>
+          <a:prstGeom prst="rect">
+            <a:avLst/>
+          </a:prstGeom>
+          <a:solidFill>
+            <a:srgbClr val="EEF4FA"/>
+          </a:solidFill>
+          <a:ln w="7620">
+            <a:solidFill>
+              <a:srgbClr val="2D6A9F"/>
+            </a:solidFill>
+            <a:prstDash val="solid"/>
+          </a:ln>
+        </p:spPr>
+      </p:sp>
+      <p:sp>
+        <p:nvSpPr>
+          <p:cNvPr id="6" name="Text 4"/>
+          <p:cNvSpPr/>
+          <p:nvPr/>
+        </p:nvSpPr>
+        <p:spPr>
+          <a:xfrm>
+            <a:off x="640080" y="6199632"/>
+            <a:ext cx="10881360" cy="292608"/>
+          </a:xfrm>
+          <a:prstGeom prst="rect">
+            <a:avLst/>
+          </a:prstGeom>
+          <a:noFill/>
+          <a:ln/>
+        </p:spPr>
+        <p:txBody>
+          <a:bodyPr wrap="square" lIns="0" tIns="0" rIns="0" bIns="0" rtlCol="0" anchor="ctr">
+            <a:normAutofit/>
+          </a:bodyPr>
+          <a:lstStyle/>
+          <a:p>
+            <a:pPr indent="0" marL="0">
+              <a:buNone/>
+            </a:pPr>
+            <a:r>
+              <a:rPr lang="en-US" sz="1000" dirty="0">
+                <a:solidFill>
+                  <a:srgbClr val="6B7280"/>
+                </a:solidFill>
+                <a:latin typeface="Times New Roman" pitchFamily="34" charset="0"/>
+                <a:ea typeface="Times New Roman" pitchFamily="34" charset="-122"/>
+                <a:cs typeface="Times New Roman" pitchFamily="34" charset="-120"/>
+              </a:rPr>
+              <a:t>Takeaway: Few classroom-ready browser tools combine playable simulation, live metrics, and automatic session logging.</a:t>
+            </a:r>
+            <a:endParaRPr lang="en-US" sz="1000" dirty="0"/>
+          </a:p>
+        </p:txBody>
+      </p:sp>
+      <p:sp>
+        <p:nvSpPr>
+          <p:cNvPr id="7" name="Text 5"/>
           <p:cNvSpPr/>
           <p:nvPr/>
         </p:nvSpPr>
@@ -2562,7 +2811,7 @@
         <p:spPr>
           <a:xfrm>
             <a:off x="685800" y="1143000"/>
-            <a:ext cx="10835640" cy="5166360"/>
+            <a:ext cx="10835640" cy="4754880"/>
           </a:xfrm>
           <a:prstGeom prst="rect">
             <a:avLst/>
@@ -2592,7 +2841,7 @@
                 <a:ea typeface="Times New Roman" pitchFamily="34" charset="-122"/>
                 <a:cs typeface="Times New Roman" pitchFamily="34" charset="-120"/>
               </a:rPr>
-              <a:t>My artifact is a single-file browser game called Mayor Climate Game.</a:t>
+              <a:t>Artifact: Vercel-hosted 12×12 grid; CNY 10M budget; coal, wind, and ground-source heat pumps; live temp / wind / carbon.</a:t>
             </a:r>
             <a:endParaRPr lang="en-US" sz="1300" dirty="0"/>
           </a:p>
@@ -2613,7 +2862,7 @@
                 <a:ea typeface="Times New Roman" pitchFamily="34" charset="-122"/>
                 <a:cs typeface="Times New Roman" pitchFamily="34" charset="-120"/>
               </a:rPr>
-              <a:t>The player acts as a mayor with a budget of 10 million yuan. The city is a 12 by 12 grid with normal areas, residential areas, ventilation corridors, wind outlets, and low basins.</a:t>
+              <a:t>Sample: N = 15 session records (10 earlier + 5 pre/post TXT exports), July 2026.</a:t>
             </a:r>
             <a:endParaRPr lang="en-US" sz="1300" dirty="0"/>
           </a:p>
@@ -2634,7 +2883,7 @@
                 <a:ea typeface="Times New Roman" pitchFamily="34" charset="-122"/>
                 <a:cs typeface="Times New Roman" pitchFamily="34" charset="-120"/>
               </a:rPr>
-              <a:t>The player can place three facilities: coal power, wind power, and ground-source heat pumps.</a:t>
+              <a:t>Flow: informed consent → pre-test (4 cognition + 2 attitude items) → one gameplay round → post-test → Supabase + TXT export.</a:t>
             </a:r>
             <a:endParaRPr lang="en-US" sz="1300" dirty="0"/>
           </a:p>
@@ -2655,7 +2904,7 @@
                 <a:ea typeface="Times New Roman" pitchFamily="34" charset="-122"/>
                 <a:cs typeface="Times New Roman" pitchFamily="34" charset="-120"/>
               </a:rPr>
-              <a:t>The page updates three indicators in real time: average temperature, average wind speed, and carbon emissions.</a:t>
+              <a:t>Measures: pre/post cognition score, budget motivation, ventilation rule item, composite score, carbon, layout JSON.</a:t>
             </a:r>
             <a:endParaRPr lang="en-US" sz="1300" dirty="0"/>
           </a:p>
@@ -2676,36 +2925,81 @@
                 <a:ea typeface="Times New Roman" pitchFamily="34" charset="-122"/>
                 <a:cs typeface="Times New Roman" pitchFamily="34" charset="-120"/>
               </a:rPr>
-              <a:t>At the end, the player answers two short questions and downloads a JSON file. The file records the layout, budget used, score, metrics, and survey answers.</a:t>
+              <a:t>Analysis: descriptive coding only; rule-based microclimate model—not CFD.</a:t>
             </a:r>
             <a:endParaRPr lang="en-US" sz="1300" dirty="0"/>
           </a:p>
-          <a:p>
-            <a:pPr marL="177800" indent="-177800">
-              <a:lnSpc>
-                <a:spcPct val="115000"/>
-              </a:lnSpc>
-              <a:buSzPct val="100000"/>
-              <a:buChar char="•"/>
-            </a:pPr>
-            <a:r>
-              <a:rPr lang="en-US" sz="1300" dirty="0">
-                <a:solidFill>
-                  <a:srgbClr val="111827"/>
-                </a:solidFill>
-                <a:latin typeface="Times New Roman" pitchFamily="34" charset="0"/>
-                <a:ea typeface="Times New Roman" pitchFamily="34" charset="-122"/>
-                <a:cs typeface="Times New Roman" pitchFamily="34" charset="-120"/>
-              </a:rPr>
-              <a:t>For the user study, I plan to invite classmates or workshop participants to play one round. I will analyze whether they choose coal power, where they place it, and whether they understand the ventilation rule.</a:t>
-            </a:r>
-            <a:endParaRPr lang="en-US" sz="1300" dirty="0"/>
-          </a:p>
-        </p:txBody>
-      </p:sp>
-      <p:sp>
-        <p:nvSpPr>
-          <p:cNvPr id="5" name="Text 3"/>
+        </p:txBody>
+      </p:sp>
+      <p:sp>
+        <p:nvSpPr>
+          <p:cNvPr id="5" name="Shape 3"/>
+          <p:cNvSpPr/>
+          <p:nvPr/>
+        </p:nvSpPr>
+        <p:spPr>
+          <a:xfrm>
+            <a:off x="502920" y="6144768"/>
+            <a:ext cx="11155680" cy="384048"/>
+          </a:xfrm>
+          <a:prstGeom prst="rect">
+            <a:avLst/>
+          </a:prstGeom>
+          <a:solidFill>
+            <a:srgbClr val="EEF4FA"/>
+          </a:solidFill>
+          <a:ln w="7620">
+            <a:solidFill>
+              <a:srgbClr val="2D6A9F"/>
+            </a:solidFill>
+            <a:prstDash val="solid"/>
+          </a:ln>
+        </p:spPr>
+      </p:sp>
+      <p:sp>
+        <p:nvSpPr>
+          <p:cNvPr id="6" name="Text 4"/>
+          <p:cNvSpPr/>
+          <p:nvPr/>
+        </p:nvSpPr>
+        <p:spPr>
+          <a:xfrm>
+            <a:off x="640080" y="6199632"/>
+            <a:ext cx="10881360" cy="292608"/>
+          </a:xfrm>
+          <a:prstGeom prst="rect">
+            <a:avLst/>
+          </a:prstGeom>
+          <a:noFill/>
+          <a:ln/>
+        </p:spPr>
+        <p:txBody>
+          <a:bodyPr wrap="square" lIns="0" tIns="0" rIns="0" bIns="0" rtlCol="0" anchor="ctr">
+            <a:normAutofit/>
+          </a:bodyPr>
+          <a:lstStyle/>
+          <a:p>
+            <a:pPr indent="0" marL="0">
+              <a:buNone/>
+            </a:pPr>
+            <a:r>
+              <a:rPr lang="en-US" sz="1000" dirty="0">
+                <a:solidFill>
+                  <a:srgbClr val="6B7280"/>
+                </a:solidFill>
+                <a:latin typeface="Times New Roman" pitchFamily="34" charset="0"/>
+                <a:ea typeface="Times New Roman" pitchFamily="34" charset="-122"/>
+                <a:cs typeface="Times New Roman" pitchFamily="34" charset="-120"/>
+              </a:rPr>
+              <a:t>Takeaway: Consent and matched pre/post items are now built into the live site; each session is linked by sessionId.</a:t>
+            </a:r>
+            <a:endParaRPr lang="en-US" sz="1000" dirty="0"/>
+          </a:p>
+        </p:txBody>
+      </p:sp>
+      <p:sp>
+        <p:nvSpPr>
+          <p:cNvPr id="7" name="Text 5"/>
           <p:cNvSpPr/>
           <p:nvPr/>
         </p:nvSpPr>
@@ -2807,7 +3101,7 @@
                 <a:ea typeface="Times New Roman" pitchFamily="34" charset="-122"/>
                 <a:cs typeface="Times New Roman" pitchFamily="34" charset="-120"/>
               </a:rPr>
-              <a:t>Research Plan &amp; Challenges</a:t>
+              <a:t>Results</a:t>
             </a:r>
             <a:endParaRPr lang="en-US" sz="2800" dirty="0"/>
           </a:p>
@@ -2845,7 +3139,7 @@
         <p:spPr>
           <a:xfrm>
             <a:off x="685800" y="1143000"/>
-            <a:ext cx="10835640" cy="5166360"/>
+            <a:ext cx="10835640" cy="4754880"/>
           </a:xfrm>
           <a:prstGeom prst="rect">
             <a:avLst/>
@@ -2875,7 +3169,7 @@
                 <a:ea typeface="Times New Roman" pitchFamily="34" charset="-122"/>
                 <a:cs typeface="Times New Roman" pitchFamily="34" charset="-120"/>
               </a:rPr>
-              <a:t>Current status: the MVP page, research folder, and spec file are already in the GitHub repository. The prototype is deployed on Vercel and can also run locally as index.html.</a:t>
+              <a:t>15/15 answered the ventilation item correctly; 11/15 reported choosing coal to save budget.</a:t>
             </a:r>
             <a:endParaRPr lang="en-US" sz="1300" dirty="0"/>
           </a:p>
@@ -2896,7 +3190,7 @@
                 <a:ea typeface="Times New Roman" pitchFamily="34" charset="-122"/>
                 <a:cs typeface="Times New Roman" pitchFamily="34" charset="-120"/>
               </a:rPr>
-              <a:t>Next steps:</a:t>
+              <a:t>0/15 placed coal on wind outlets.</a:t>
             </a:r>
             <a:endParaRPr lang="en-US" sz="1300" dirty="0"/>
           </a:p>
@@ -2917,7 +3211,7 @@
                 <a:ea typeface="Times New Roman" pitchFamily="34" charset="-122"/>
                 <a:cs typeface="Times New Roman" pitchFamily="34" charset="-120"/>
               </a:rPr>
-              <a:t>Polish the page and deploy it online.</a:t>
+              <a:t>Score range 51–88 (mean ≈ 76.9); carbon 0–1440 t (mean ≈ 438).</a:t>
             </a:r>
             <a:endParaRPr lang="en-US" sz="1300" dirty="0"/>
           </a:p>
@@ -2938,7 +3232,7 @@
                 <a:ea typeface="Times New Roman" pitchFamily="34" charset="-122"/>
                 <a:cs typeface="Times New Roman" pitchFamily="34" charset="-120"/>
               </a:rPr>
-              <a:t>Ask several classmates to play one short round.</a:t>
+              <a:t>Low carbon (0–120 t, n=9): scores mostly 84–88; high carbon (240–1440 t, n=6): scores 51–81</a:t>
             </a:r>
             <a:endParaRPr lang="en-US" sz="1300" dirty="0"/>
           </a:p>
@@ -2959,7 +3253,7 @@
                 <a:ea typeface="Times New Roman" pitchFamily="34" charset="-122"/>
                 <a:cs typeface="Times New Roman" pitchFamily="34" charset="-120"/>
               </a:rPr>
-              <a:t>Collect the exported JSON files.</a:t>
+              <a:t>Pre/post subset (n=5): cognition 3/4 → 3/4 (no change in this subset).</a:t>
             </a:r>
             <a:endParaRPr lang="en-US" sz="1300" dirty="0"/>
           </a:p>
@@ -2980,141 +3274,81 @@
                 <a:ea typeface="Times New Roman" pitchFamily="34" charset="-122"/>
                 <a:cs typeface="Times New Roman" pitchFamily="34" charset="-120"/>
               </a:rPr>
-              <a:t>Compare layouts, carbon emissions, budget use, and answers to the two questions.</a:t>
+              <a:t>No inferential tests—exploratory pilot only.</a:t>
             </a:r>
             <a:endParaRPr lang="en-US" sz="1300" dirty="0"/>
           </a:p>
-          <a:p>
-            <a:pPr marL="177800" indent="-177800">
-              <a:lnSpc>
-                <a:spcPct val="115000"/>
-              </a:lnSpc>
-              <a:buSzPct val="100000"/>
-              <a:buChar char="•"/>
-            </a:pPr>
-            <a:r>
-              <a:rPr lang="en-US" sz="1300" dirty="0">
-                <a:solidFill>
-                  <a:srgbClr val="111827"/>
-                </a:solidFill>
-                <a:latin typeface="Times New Roman" pitchFamily="34" charset="0"/>
-                <a:ea typeface="Times New Roman" pitchFamily="34" charset="-122"/>
-                <a:cs typeface="Times New Roman" pitchFamily="34" charset="-120"/>
-              </a:rPr>
-              <a:t>Decide whether the questionnaire needs one open-ended question.</a:t>
-            </a:r>
-            <a:endParaRPr lang="en-US" sz="1300" dirty="0"/>
-          </a:p>
-          <a:p>
-            <a:pPr marL="177800" indent="-177800">
-              <a:lnSpc>
-                <a:spcPct val="115000"/>
-              </a:lnSpc>
-              <a:buSzPct val="100000"/>
-              <a:buChar char="•"/>
-            </a:pPr>
-            <a:r>
-              <a:rPr lang="en-US" sz="1300" dirty="0">
-                <a:solidFill>
-                  <a:srgbClr val="111827"/>
-                </a:solidFill>
-                <a:latin typeface="Times New Roman" pitchFamily="34" charset="0"/>
-                <a:ea typeface="Times New Roman" pitchFamily="34" charset="-122"/>
-                <a:cs typeface="Times New Roman" pitchFamily="34" charset="-120"/>
-              </a:rPr>
-              <a:t>Main challenges:</a:t>
-            </a:r>
-            <a:endParaRPr lang="en-US" sz="1300" dirty="0"/>
-          </a:p>
-          <a:p>
-            <a:pPr marL="177800" indent="-177800">
-              <a:lnSpc>
-                <a:spcPct val="115000"/>
-              </a:lnSpc>
-              <a:buSzPct val="100000"/>
-              <a:buChar char="•"/>
-            </a:pPr>
-            <a:r>
-              <a:rPr lang="en-US" sz="1300" dirty="0">
-                <a:solidFill>
-                  <a:srgbClr val="111827"/>
-                </a:solidFill>
-                <a:latin typeface="Times New Roman" pitchFamily="34" charset="0"/>
-                <a:ea typeface="Times New Roman" pitchFamily="34" charset="-122"/>
-                <a:cs typeface="Times New Roman" pitchFamily="34" charset="-120"/>
-              </a:rPr>
-              <a:t>The physics model is simplified, so I cannot claim it is a real city simulation.</a:t>
-            </a:r>
-            <a:endParaRPr lang="en-US" sz="1300" dirty="0"/>
-          </a:p>
-          <a:p>
-            <a:pPr marL="177800" indent="-177800">
-              <a:lnSpc>
-                <a:spcPct val="115000"/>
-              </a:lnSpc>
-              <a:buSzPct val="100000"/>
-              <a:buChar char="•"/>
-            </a:pPr>
-            <a:r>
-              <a:rPr lang="en-US" sz="1300" dirty="0">
-                <a:solidFill>
-                  <a:srgbClr val="111827"/>
-                </a:solidFill>
-                <a:latin typeface="Times New Roman" pitchFamily="34" charset="0"/>
-                <a:ea typeface="Times New Roman" pitchFamily="34" charset="-122"/>
-                <a:cs typeface="Times New Roman" pitchFamily="34" charset="-120"/>
-              </a:rPr>
-              <a:t>The sample size may be small.</a:t>
-            </a:r>
-            <a:endParaRPr lang="en-US" sz="1300" dirty="0"/>
-          </a:p>
-          <a:p>
-            <a:pPr marL="177800" indent="-177800">
-              <a:lnSpc>
-                <a:spcPct val="115000"/>
-              </a:lnSpc>
-              <a:buSzPct val="100000"/>
-              <a:buChar char="•"/>
-            </a:pPr>
-            <a:r>
-              <a:rPr lang="en-US" sz="1300" dirty="0">
-                <a:solidFill>
-                  <a:srgbClr val="111827"/>
-                </a:solidFill>
-                <a:latin typeface="Times New Roman" pitchFamily="34" charset="0"/>
-                <a:ea typeface="Times New Roman" pitchFamily="34" charset="-122"/>
-                <a:cs typeface="Times New Roman" pitchFamily="34" charset="-120"/>
-              </a:rPr>
-              <a:t>Some players may treat the page as a game only, not as a research task.</a:t>
-            </a:r>
-            <a:endParaRPr lang="en-US" sz="1300" dirty="0"/>
-          </a:p>
-          <a:p>
-            <a:pPr marL="177800" indent="-177800">
-              <a:lnSpc>
-                <a:spcPct val="115000"/>
-              </a:lnSpc>
-              <a:buSzPct val="100000"/>
-              <a:buChar char="•"/>
-            </a:pPr>
-            <a:r>
-              <a:rPr lang="en-US" sz="1300" dirty="0">
-                <a:solidFill>
-                  <a:srgbClr val="111827"/>
-                </a:solidFill>
-                <a:latin typeface="Times New Roman" pitchFamily="34" charset="0"/>
-                <a:ea typeface="Times New Roman" pitchFamily="34" charset="-122"/>
-                <a:cs typeface="Times New Roman" pitchFamily="34" charset="-120"/>
-              </a:rPr>
-              <a:t>The Vercel site is live, but some networks may have trouble opening vercel.app, so I will keep the local file as a backup.</a:t>
-            </a:r>
-            <a:endParaRPr lang="en-US" sz="1300" dirty="0"/>
-          </a:p>
-        </p:txBody>
-      </p:sp>
-      <p:sp>
-        <p:nvSpPr>
-          <p:cNvPr id="5" name="Text 3"/>
+        </p:txBody>
+      </p:sp>
+      <p:sp>
+        <p:nvSpPr>
+          <p:cNvPr id="5" name="Shape 3"/>
+          <p:cNvSpPr/>
+          <p:nvPr/>
+        </p:nvSpPr>
+        <p:spPr>
+          <a:xfrm>
+            <a:off x="502920" y="6144768"/>
+            <a:ext cx="11155680" cy="384048"/>
+          </a:xfrm>
+          <a:prstGeom prst="rect">
+            <a:avLst/>
+          </a:prstGeom>
+          <a:solidFill>
+            <a:srgbClr val="EEF4FA"/>
+          </a:solidFill>
+          <a:ln w="7620">
+            <a:solidFill>
+              <a:srgbClr val="2D6A9F"/>
+            </a:solidFill>
+            <a:prstDash val="solid"/>
+          </a:ln>
+        </p:spPr>
+      </p:sp>
+      <p:sp>
+        <p:nvSpPr>
+          <p:cNvPr id="6" name="Text 4"/>
+          <p:cNvSpPr/>
+          <p:nvPr/>
+        </p:nvSpPr>
+        <p:spPr>
+          <a:xfrm>
+            <a:off x="640080" y="6199632"/>
+            <a:ext cx="10881360" cy="292608"/>
+          </a:xfrm>
+          <a:prstGeom prst="rect">
+            <a:avLst/>
+          </a:prstGeom>
+          <a:noFill/>
+          <a:ln/>
+        </p:spPr>
+        <p:txBody>
+          <a:bodyPr wrap="square" lIns="0" tIns="0" rIns="0" bIns="0" rtlCol="0" anchor="ctr">
+            <a:normAutofit/>
+          </a:bodyPr>
+          <a:lstStyle/>
+          <a:p>
+            <a:pPr indent="0" marL="0">
+              <a:buNone/>
+            </a:pPr>
+            <a:r>
+              <a:rPr lang="en-US" sz="1000" dirty="0">
+                <a:solidFill>
+                  <a:srgbClr val="6B7280"/>
+                </a:solidFill>
+                <a:latin typeface="Times New Roman" pitchFamily="34" charset="0"/>
+                <a:ea typeface="Times New Roman" pitchFamily="34" charset="-122"/>
+                <a:cs typeface="Times New Roman" pitchFamily="34" charset="-120"/>
+              </a:rPr>
+              <a:t>Takeaway: 15/15 knew ventilation rules; 0 blocked outlets. Carbon 0–1440 t—clean layouts scored higher.</a:t>
+            </a:r>
+            <a:endParaRPr lang="en-US" sz="1000" dirty="0"/>
+          </a:p>
+        </p:txBody>
+      </p:sp>
+      <p:sp>
+        <p:nvSpPr>
+          <p:cNvPr id="7" name="Text 5"/>
           <p:cNvSpPr/>
           <p:nvPr/>
         </p:nvSpPr>
@@ -3216,7 +3450,7 @@
                 <a:ea typeface="Times New Roman" pitchFamily="34" charset="-122"/>
                 <a:cs typeface="Times New Roman" pitchFamily="34" charset="-120"/>
               </a:rPr>
-              <a:t>Expected Results — user study not yet run</a:t>
+              <a:t>Discussion, Demo &amp; Limitations</a:t>
             </a:r>
             <a:endParaRPr lang="en-US" sz="2800" dirty="0"/>
           </a:p>
@@ -3253,8 +3487,8 @@
         </p:nvSpPr>
         <p:spPr>
           <a:xfrm>
-            <a:off x="685800" y="1188720"/>
-            <a:ext cx="5715000" cy="5074920"/>
+            <a:off x="685800" y="1143000"/>
+            <a:ext cx="5806440" cy="4480560"/>
           </a:xfrm>
           <a:prstGeom prst="rect">
             <a:avLst/>
@@ -3276,7 +3510,7 @@
               <a:buChar char="•"/>
             </a:pPr>
             <a:r>
-              <a:rPr lang="en-US" sz="1400" dirty="0">
+              <a:rPr lang="en-US" sz="1300" dirty="0">
                 <a:solidFill>
                   <a:srgbClr val="111827"/>
                 </a:solidFill>
@@ -3284,9 +3518,9 @@
                 <a:ea typeface="Times New Roman" pitchFamily="34" charset="-122"/>
                 <a:cs typeface="Times New Roman" pitchFamily="34" charset="-120"/>
               </a:rPr>
-              <a:t>The user study has not been run yet.</a:t>
-            </a:r>
-            <a:endParaRPr lang="en-US" sz="1400" dirty="0"/>
+              <a:t>Findings partially support the hypothesis: strong ventilation knowledge; no coal on outlets.</a:t>
+            </a:r>
+            <a:endParaRPr lang="en-US" sz="1300" dirty="0"/>
           </a:p>
           <a:p>
             <a:pPr marL="177800" indent="-177800">
@@ -3297,7 +3531,7 @@
               <a:buChar char="•"/>
             </a:pPr>
             <a:r>
-              <a:rPr lang="en-US" sz="1400" dirty="0">
+              <a:rPr lang="en-US" sz="1300" dirty="0">
                 <a:solidFill>
                   <a:srgbClr val="111827"/>
                 </a:solidFill>
@@ -3305,9 +3539,9 @@
                 <a:ea typeface="Times New Roman" pitchFamily="34" charset="-122"/>
                 <a:cs typeface="Times New Roman" pitchFamily="34" charset="-120"/>
               </a:rPr>
-              <a:t>I expect some students will first choose coal because it is cheaper.</a:t>
-            </a:r>
-            <a:endParaRPr lang="en-US" sz="1400" dirty="0"/>
+              <a:t>Budget pressure remains salient (11/15), yet 4/15 chose zero-coal layouts.</a:t>
+            </a:r>
+            <a:endParaRPr lang="en-US" sz="1300" dirty="0"/>
           </a:p>
           <a:p>
             <a:pPr marL="177800" indent="-177800">
@@ -3318,7 +3552,7 @@
               <a:buChar char="•"/>
             </a:pPr>
             <a:r>
-              <a:rPr lang="en-US" sz="1400" dirty="0">
+              <a:rPr lang="en-US" sz="1300" dirty="0">
                 <a:solidFill>
                   <a:srgbClr val="111827"/>
                 </a:solidFill>
@@ -3326,9 +3560,9 @@
                 <a:ea typeface="Times New Roman" pitchFamily="34" charset="-122"/>
                 <a:cs typeface="Times New Roman" pitchFamily="34" charset="-120"/>
               </a:rPr>
-              <a:t>I also expect that after seeing carbon emissions and ventilation feedback, some students will shift toward wind power or heat pumps.</a:t>
-            </a:r>
-            <a:endParaRPr lang="en-US" sz="1400" dirty="0"/>
+              <a:t>Carbon outcomes vary by facility mix—not stated motivation alone.</a:t>
+            </a:r>
+            <a:endParaRPr lang="en-US" sz="1300" dirty="0"/>
           </a:p>
           <a:p>
             <a:pPr marL="177800" indent="-177800">
@@ -3339,7 +3573,7 @@
               <a:buChar char="•"/>
             </a:pPr>
             <a:r>
-              <a:rPr lang="en-US" sz="1400" dirty="0">
+              <a:rPr lang="en-US" sz="1300" dirty="0">
                 <a:solidFill>
                   <a:srgbClr val="111827"/>
                 </a:solidFill>
@@ -3347,9 +3581,9 @@
                 <a:ea typeface="Times New Roman" pitchFamily="34" charset="-122"/>
                 <a:cs typeface="Times New Roman" pitchFamily="34" charset="-120"/>
               </a:rPr>
-              <a:t>I expect the JSON files to show different strategies: low-cost coal-heavy layouts, cleaner but more expensive layouts, and mixed layouts.</a:t>
-            </a:r>
-            <a:endParaRPr lang="en-US" sz="1400" dirty="0"/>
+              <a:t>Limitations: N=15 session records; simplified model; pre/post subset too small for gain claims.</a:t>
+            </a:r>
+            <a:endParaRPr lang="en-US" sz="1300" dirty="0"/>
           </a:p>
           <a:p>
             <a:pPr marL="177800" indent="-177800">
@@ -3360,7 +3594,7 @@
               <a:buChar char="•"/>
             </a:pPr>
             <a:r>
-              <a:rPr lang="en-US" sz="1400" dirty="0">
+              <a:rPr lang="en-US" sz="1300" dirty="0">
                 <a:solidFill>
                   <a:srgbClr val="111827"/>
                 </a:solidFill>
@@ -3368,9 +3602,9 @@
                 <a:ea typeface="Times New Roman" pitchFamily="34" charset="-122"/>
                 <a:cs typeface="Times New Roman" pitchFamily="34" charset="-120"/>
               </a:rPr>
-              <a:t>I will not report user numbers, percentages, or conclusions until I collect real user data.</a:t>
-            </a:r>
-            <a:endParaRPr lang="en-US" sz="1400" dirty="0"/>
+              <a:t>Live demo: mayor-climate-game.vercel.app</a:t>
+            </a:r>
+            <a:endParaRPr lang="en-US" sz="1300" dirty="0"/>
           </a:p>
         </p:txBody>
       </p:sp>
@@ -3395,7 +3629,7 @@
           </a:solidFill>
           <a:ln w="15240">
             <a:solidFill>
-              <a:srgbClr val="8A95A3"/>
+              <a:srgbClr val="2D6A9F"/>
             </a:solidFill>
             <a:prstDash val="solid"/>
           </a:ln>
@@ -3409,8 +3643,8 @@
         </p:nvSpPr>
         <p:spPr>
           <a:xfrm>
-            <a:off x="7086600" y="2944368"/>
-            <a:ext cx="3977640" cy="411480"/>
+            <a:off x="7086600" y="2788920"/>
+            <a:ext cx="3977640" cy="822960"/>
           </a:xfrm>
           <a:prstGeom prst="rect">
             <a:avLst/>
@@ -3426,7 +3660,63 @@
               <a:buNone/>
             </a:pPr>
             <a:r>
-              <a:rPr lang="en-US" sz="1600" i="1" dirty="0">
+              <a:rPr lang="en-US" sz="1800" b="1" dirty="0">
+                <a:solidFill>
+                  <a:srgbClr val="173B5F"/>
+                </a:solidFill>
+                <a:latin typeface="Times New Roman" pitchFamily="34" charset="0"/>
+                <a:ea typeface="Times New Roman" pitchFamily="34" charset="-122"/>
+                <a:cs typeface="Times New Roman" pitchFamily="34" charset="-120"/>
+              </a:rPr>
+              <a:t>mayor-climate-game</a:t>
+            </a:r>
+            <a:endParaRPr lang="en-US" sz="1800" dirty="0"/>
+          </a:p>
+          <a:p>
+            <a:pPr algn="ctr" indent="0" marL="0">
+              <a:buNone/>
+            </a:pPr>
+            <a:r>
+              <a:rPr lang="en-US" sz="1800" b="1" dirty="0">
+                <a:solidFill>
+                  <a:srgbClr val="173B5F"/>
+                </a:solidFill>
+                <a:latin typeface="Times New Roman" pitchFamily="34" charset="0"/>
+                <a:ea typeface="Times New Roman" pitchFamily="34" charset="-122"/>
+                <a:cs typeface="Times New Roman" pitchFamily="34" charset="-120"/>
+              </a:rPr>
+              <a:t>.vercel.app</a:t>
+            </a:r>
+            <a:endParaRPr lang="en-US" sz="1800" dirty="0"/>
+          </a:p>
+        </p:txBody>
+      </p:sp>
+      <p:sp>
+        <p:nvSpPr>
+          <p:cNvPr id="7" name="Text 5"/>
+          <p:cNvSpPr/>
+          <p:nvPr/>
+        </p:nvSpPr>
+        <p:spPr>
+          <a:xfrm>
+            <a:off x="7086600" y="3657600"/>
+            <a:ext cx="3977640" cy="320040"/>
+          </a:xfrm>
+          <a:prstGeom prst="rect">
+            <a:avLst/>
+          </a:prstGeom>
+          <a:noFill/>
+          <a:ln/>
+        </p:spPr>
+        <p:txBody>
+          <a:bodyPr wrap="square" lIns="0" tIns="0" rIns="0" bIns="0" rtlCol="0" anchor="ctr"/>
+          <a:lstStyle/>
+          <a:p>
+            <a:pPr algn="ctr" indent="0" marL="0">
+              <a:buNone/>
+            </a:pPr>
+            <a:r>
+              <a:rPr lang="en-US" sz="1200" i="1" dirty="0">
                 <a:solidFill>
                   <a:srgbClr val="6B7280"/>
                 </a:solidFill>
@@ -3434,15 +3724,81 @@
                 <a:ea typeface="Times New Roman" pitchFamily="34" charset="-122"/>
                 <a:cs typeface="Times New Roman" pitchFamily="34" charset="-120"/>
               </a:rPr>
-              <a:t>Insert prototype screenshot here</a:t>
-            </a:r>
-            <a:endParaRPr lang="en-US" sz="1600" dirty="0"/>
-          </a:p>
-        </p:txBody>
-      </p:sp>
-      <p:sp>
-        <p:nvSpPr>
-          <p:cNvPr id="7" name="Text 5"/>
+              <a:t>Insert screenshot or QR here</a:t>
+            </a:r>
+            <a:endParaRPr lang="en-US" sz="1200" dirty="0"/>
+          </a:p>
+        </p:txBody>
+      </p:sp>
+      <p:sp>
+        <p:nvSpPr>
+          <p:cNvPr id="8" name="Shape 6"/>
+          <p:cNvSpPr/>
+          <p:nvPr/>
+        </p:nvSpPr>
+        <p:spPr>
+          <a:xfrm>
+            <a:off x="502920" y="6144768"/>
+            <a:ext cx="11155680" cy="384048"/>
+          </a:xfrm>
+          <a:prstGeom prst="rect">
+            <a:avLst/>
+          </a:prstGeom>
+          <a:solidFill>
+            <a:srgbClr val="EEF4FA"/>
+          </a:solidFill>
+          <a:ln w="7620">
+            <a:solidFill>
+              <a:srgbClr val="2D6A9F"/>
+            </a:solidFill>
+            <a:prstDash val="solid"/>
+          </a:ln>
+        </p:spPr>
+      </p:sp>
+      <p:sp>
+        <p:nvSpPr>
+          <p:cNvPr id="9" name="Text 7"/>
+          <p:cNvSpPr/>
+          <p:nvPr/>
+        </p:nvSpPr>
+        <p:spPr>
+          <a:xfrm>
+            <a:off x="640080" y="6199632"/>
+            <a:ext cx="10881360" cy="292608"/>
+          </a:xfrm>
+          <a:prstGeom prst="rect">
+            <a:avLst/>
+          </a:prstGeom>
+          <a:noFill/>
+          <a:ln/>
+        </p:spPr>
+        <p:txBody>
+          <a:bodyPr wrap="square" lIns="0" tIns="0" rIns="0" bIns="0" rtlCol="0" anchor="ctr">
+            <a:normAutofit/>
+          </a:bodyPr>
+          <a:lstStyle/>
+          <a:p>
+            <a:pPr indent="0" marL="0">
+              <a:buNone/>
+            </a:pPr>
+            <a:r>
+              <a:rPr lang="en-US" sz="1000" dirty="0">
+                <a:solidFill>
+                  <a:srgbClr val="6B7280"/>
+                </a:solidFill>
+                <a:latin typeface="Times New Roman" pitchFamily="34" charset="0"/>
+                <a:ea typeface="Times New Roman" pitchFamily="34" charset="-122"/>
+                <a:cs typeface="Times New Roman" pitchFamily="34" charset="-120"/>
+              </a:rPr>
+              <a:t>Takeaway: Short browser play makes tradeoffs concrete; sample is exploratory—do not over-generalize beyond these 15 sessions.</a:t>
+            </a:r>
+            <a:endParaRPr lang="en-US" sz="1000" dirty="0"/>
+          </a:p>
+        </p:txBody>
+      </p:sp>
+      <p:sp>
+        <p:nvSpPr>
+          <p:cNvPr id="10" name="Text 8"/>
           <p:cNvSpPr/>
           <p:nvPr/>
         </p:nvSpPr>
@@ -3582,7 +3938,7 @@
         <p:spPr>
           <a:xfrm>
             <a:off x="685800" y="1051560"/>
-            <a:ext cx="10835640" cy="5303520"/>
+            <a:ext cx="10835640" cy="4754880"/>
           </a:xfrm>
           <a:prstGeom prst="rect">
             <a:avLst/>
@@ -3706,7 +4062,73 @@
       </p:sp>
       <p:sp>
         <p:nvSpPr>
-          <p:cNvPr id="5" name="Text 3"/>
+          <p:cNvPr id="5" name="Shape 3"/>
+          <p:cNvSpPr/>
+          <p:nvPr/>
+        </p:nvSpPr>
+        <p:spPr>
+          <a:xfrm>
+            <a:off x="502920" y="6144768"/>
+            <a:ext cx="11155680" cy="384048"/>
+          </a:xfrm>
+          <a:prstGeom prst="rect">
+            <a:avLst/>
+          </a:prstGeom>
+          <a:solidFill>
+            <a:srgbClr val="EEF4FA"/>
+          </a:solidFill>
+          <a:ln w="7620">
+            <a:solidFill>
+              <a:srgbClr val="2D6A9F"/>
+            </a:solidFill>
+            <a:prstDash val="solid"/>
+          </a:ln>
+        </p:spPr>
+      </p:sp>
+      <p:sp>
+        <p:nvSpPr>
+          <p:cNvPr id="6" name="Text 4"/>
+          <p:cNvSpPr/>
+          <p:nvPr/>
+        </p:nvSpPr>
+        <p:spPr>
+          <a:xfrm>
+            <a:off x="640080" y="6199632"/>
+            <a:ext cx="10881360" cy="292608"/>
+          </a:xfrm>
+          <a:prstGeom prst="rect">
+            <a:avLst/>
+          </a:prstGeom>
+          <a:noFill/>
+          <a:ln/>
+        </p:spPr>
+        <p:txBody>
+          <a:bodyPr wrap="square" lIns="0" tIns="0" rIns="0" bIns="0" rtlCol="0" anchor="ctr">
+            <a:normAutofit/>
+          </a:bodyPr>
+          <a:lstStyle/>
+          <a:p>
+            <a:pPr indent="0" marL="0">
+              <a:buNone/>
+            </a:pPr>
+            <a:r>
+              <a:rPr lang="en-US" sz="1000" dirty="0">
+                <a:solidFill>
+                  <a:srgbClr val="6B7280"/>
+                </a:solidFill>
+                <a:latin typeface="Times New Roman" pitchFamily="34" charset="0"/>
+                <a:ea typeface="Times New Roman" pitchFamily="34" charset="-122"/>
+                <a:cs typeface="Times New Roman" pitchFamily="34" charset="-120"/>
+              </a:rPr>
+              <a:t>Takeaway: References cover cooling demand, ventilation corridors, and serious-game methods.</a:t>
+            </a:r>
+            <a:endParaRPr lang="en-US" sz="1000" dirty="0"/>
+          </a:p>
+        </p:txBody>
+      </p:sp>
+      <p:sp>
+        <p:nvSpPr>
+          <p:cNvPr id="7" name="Text 5"/>
           <p:cNvSpPr/>
           <p:nvPr/>
         </p:nvSpPr>
@@ -3875,7 +4297,7 @@
                 <a:ea typeface="Times New Roman" pitchFamily="34" charset="-122"/>
                 <a:cs typeface="Times New Roman" pitchFamily="34" charset="-120"/>
               </a:rPr>
-              <a:t>Thank you to Lawted Wu for the course structure, comments, and guidance.</a:t>
+              <a:t>Thank you to Lawted Wu for course structure, GitHub feedback, and research design guidance.</a:t>
             </a:r>
             <a:endParaRPr lang="en-US" sz="1800" dirty="0"/>
           </a:p>
@@ -3904,15 +4326,110 @@
                 <a:ea typeface="Times New Roman" pitchFamily="34" charset="-122"/>
                 <a:cs typeface="Times New Roman" pitchFamily="34" charset="-120"/>
               </a:rPr>
-              <a:t>Thank you to my classmates for future testing and feedback.</a:t>
+              <a:t>Thank you to classmates and volunteers who tested the game and contributed session data.</a:t>
             </a:r>
             <a:endParaRPr lang="en-US" sz="1800" dirty="0"/>
           </a:p>
-        </p:txBody>
-      </p:sp>
-      <p:sp>
-        <p:nvSpPr>
-          <p:cNvPr id="5" name="Text 3"/>
+          <a:p>
+            <a:pPr indent="0" marL="0">
+              <a:lnSpc>
+                <a:spcPct val="115000"/>
+              </a:lnSpc>
+              <a:buNone/>
+            </a:pPr>
+            <a:endParaRPr lang="en-US" sz="1800" dirty="0"/>
+          </a:p>
+          <a:p>
+            <a:pPr indent="0" marL="0">
+              <a:lnSpc>
+                <a:spcPct val="115000"/>
+              </a:lnSpc>
+              <a:buNone/>
+            </a:pPr>
+            <a:r>
+              <a:rPr lang="en-US" sz="1800" dirty="0">
+                <a:solidFill>
+                  <a:srgbClr val="111827"/>
+                </a:solidFill>
+                <a:latin typeface="Times New Roman" pitchFamily="34" charset="0"/>
+                <a:ea typeface="Times New Roman" pitchFamily="34" charset="-122"/>
+                <a:cs typeface="Times New Roman" pitchFamily="34" charset="-120"/>
+              </a:rPr>
+              <a:t>Thank you for your attention—questions welcome.</a:t>
+            </a:r>
+            <a:endParaRPr lang="en-US" sz="1800" dirty="0"/>
+          </a:p>
+        </p:txBody>
+      </p:sp>
+      <p:sp>
+        <p:nvSpPr>
+          <p:cNvPr id="5" name="Shape 3"/>
+          <p:cNvSpPr/>
+          <p:nvPr/>
+        </p:nvSpPr>
+        <p:spPr>
+          <a:xfrm>
+            <a:off x="502920" y="6144768"/>
+            <a:ext cx="11155680" cy="384048"/>
+          </a:xfrm>
+          <a:prstGeom prst="rect">
+            <a:avLst/>
+          </a:prstGeom>
+          <a:solidFill>
+            <a:srgbClr val="EEF4FA"/>
+          </a:solidFill>
+          <a:ln w="7620">
+            <a:solidFill>
+              <a:srgbClr val="2D6A9F"/>
+            </a:solidFill>
+            <a:prstDash val="solid"/>
+          </a:ln>
+        </p:spPr>
+      </p:sp>
+      <p:sp>
+        <p:nvSpPr>
+          <p:cNvPr id="6" name="Text 4"/>
+          <p:cNvSpPr/>
+          <p:nvPr/>
+        </p:nvSpPr>
+        <p:spPr>
+          <a:xfrm>
+            <a:off x="640080" y="6199632"/>
+            <a:ext cx="10881360" cy="292608"/>
+          </a:xfrm>
+          <a:prstGeom prst="rect">
+            <a:avLst/>
+          </a:prstGeom>
+          <a:noFill/>
+          <a:ln/>
+        </p:spPr>
+        <p:txBody>
+          <a:bodyPr wrap="square" lIns="0" tIns="0" rIns="0" bIns="0" rtlCol="0" anchor="ctr">
+            <a:normAutofit/>
+          </a:bodyPr>
+          <a:lstStyle/>
+          <a:p>
+            <a:pPr indent="0" marL="0">
+              <a:buNone/>
+            </a:pPr>
+            <a:r>
+              <a:rPr lang="en-US" sz="1000" dirty="0">
+                <a:solidFill>
+                  <a:srgbClr val="6B7280"/>
+                </a:solidFill>
+                <a:latin typeface="Times New Roman" pitchFamily="34" charset="0"/>
+                <a:ea typeface="Times New Roman" pitchFamily="34" charset="-122"/>
+                <a:cs typeface="Times New Roman" pitchFamily="34" charset="-120"/>
+              </a:rPr>
+              <a:t>Takeaway: Thank you for your constructive feedback.</a:t>
+            </a:r>
+            <a:endParaRPr lang="en-US" sz="1000" dirty="0"/>
+          </a:p>
+        </p:txBody>
+      </p:sp>
+      <p:sp>
+        <p:nvSpPr>
+          <p:cNvPr id="7" name="Text 5"/>
           <p:cNvSpPr/>
           <p:nvPr/>
         </p:nvSpPr>

</xml_diff>